<commit_message>
Modification of the description of the CabinetPower module
</commit_message>
<xml_diff>
--- a/Information/Graphs.pptx
+++ b/Information/Graphs.pptx
@@ -110,7 +110,7 @@
   </p:defaultTextStyle>
   <p:extLst>
     <p:ext uri="{EFAFB233-063F-42B5-8137-9DF3F51BA10A}">
-      <p15:sldGuideLst xmlns:p15="http://schemas.microsoft.com/office/powerpoint/2012/main"/>
+      <p15:sldGuideLst xmlns:p15="http://schemas.microsoft.com/office/powerpoint/2012/main" xmlns=""/>
     </p:ext>
   </p:extLst>
 </p:presentation>
@@ -247,7 +247,7 @@
           <a:p>
             <a:fld id="{9C2A1DF7-758F-4EF0-A019-330F45C81B70}" type="datetimeFigureOut">
               <a:rPr lang="en-GB" smtClean="0"/>
-              <a:t>12/02/2020</a:t>
+              <a:t>10/04/2020</a:t>
             </a:fld>
             <a:endParaRPr lang="en-GB"/>
           </a:p>
@@ -417,7 +417,7 @@
           <a:p>
             <a:fld id="{9C2A1DF7-758F-4EF0-A019-330F45C81B70}" type="datetimeFigureOut">
               <a:rPr lang="en-GB" smtClean="0"/>
-              <a:t>12/02/2020</a:t>
+              <a:t>10/04/2020</a:t>
             </a:fld>
             <a:endParaRPr lang="en-GB"/>
           </a:p>
@@ -597,7 +597,7 @@
           <a:p>
             <a:fld id="{9C2A1DF7-758F-4EF0-A019-330F45C81B70}" type="datetimeFigureOut">
               <a:rPr lang="en-GB" smtClean="0"/>
-              <a:t>12/02/2020</a:t>
+              <a:t>10/04/2020</a:t>
             </a:fld>
             <a:endParaRPr lang="en-GB"/>
           </a:p>
@@ -767,7 +767,7 @@
           <a:p>
             <a:fld id="{9C2A1DF7-758F-4EF0-A019-330F45C81B70}" type="datetimeFigureOut">
               <a:rPr lang="en-GB" smtClean="0"/>
-              <a:t>12/02/2020</a:t>
+              <a:t>10/04/2020</a:t>
             </a:fld>
             <a:endParaRPr lang="en-GB"/>
           </a:p>
@@ -1013,7 +1013,7 @@
           <a:p>
             <a:fld id="{9C2A1DF7-758F-4EF0-A019-330F45C81B70}" type="datetimeFigureOut">
               <a:rPr lang="en-GB" smtClean="0"/>
-              <a:t>12/02/2020</a:t>
+              <a:t>10/04/2020</a:t>
             </a:fld>
             <a:endParaRPr lang="en-GB"/>
           </a:p>
@@ -1245,7 +1245,7 @@
           <a:p>
             <a:fld id="{9C2A1DF7-758F-4EF0-A019-330F45C81B70}" type="datetimeFigureOut">
               <a:rPr lang="en-GB" smtClean="0"/>
-              <a:t>12/02/2020</a:t>
+              <a:t>10/04/2020</a:t>
             </a:fld>
             <a:endParaRPr lang="en-GB"/>
           </a:p>
@@ -1612,7 +1612,7 @@
           <a:p>
             <a:fld id="{9C2A1DF7-758F-4EF0-A019-330F45C81B70}" type="datetimeFigureOut">
               <a:rPr lang="en-GB" smtClean="0"/>
-              <a:t>12/02/2020</a:t>
+              <a:t>10/04/2020</a:t>
             </a:fld>
             <a:endParaRPr lang="en-GB"/>
           </a:p>
@@ -1730,7 +1730,7 @@
           <a:p>
             <a:fld id="{9C2A1DF7-758F-4EF0-A019-330F45C81B70}" type="datetimeFigureOut">
               <a:rPr lang="en-GB" smtClean="0"/>
-              <a:t>12/02/2020</a:t>
+              <a:t>10/04/2020</a:t>
             </a:fld>
             <a:endParaRPr lang="en-GB"/>
           </a:p>
@@ -1825,7 +1825,7 @@
           <a:p>
             <a:fld id="{9C2A1DF7-758F-4EF0-A019-330F45C81B70}" type="datetimeFigureOut">
               <a:rPr lang="en-GB" smtClean="0"/>
-              <a:t>12/02/2020</a:t>
+              <a:t>10/04/2020</a:t>
             </a:fld>
             <a:endParaRPr lang="en-GB"/>
           </a:p>
@@ -2102,7 +2102,7 @@
           <a:p>
             <a:fld id="{9C2A1DF7-758F-4EF0-A019-330F45C81B70}" type="datetimeFigureOut">
               <a:rPr lang="en-GB" smtClean="0"/>
-              <a:t>12/02/2020</a:t>
+              <a:t>10/04/2020</a:t>
             </a:fld>
             <a:endParaRPr lang="en-GB"/>
           </a:p>
@@ -2355,7 +2355,7 @@
           <a:p>
             <a:fld id="{9C2A1DF7-758F-4EF0-A019-330F45C81B70}" type="datetimeFigureOut">
               <a:rPr lang="en-GB" smtClean="0"/>
-              <a:t>12/02/2020</a:t>
+              <a:t>10/04/2020</a:t>
             </a:fld>
             <a:endParaRPr lang="en-GB"/>
           </a:p>
@@ -2568,7 +2568,7 @@
           <a:p>
             <a:fld id="{9C2A1DF7-758F-4EF0-A019-330F45C81B70}" type="datetimeFigureOut">
               <a:rPr lang="en-GB" smtClean="0"/>
-              <a:t>12/02/2020</a:t>
+              <a:t>10/04/2020</a:t>
             </a:fld>
             <a:endParaRPr lang="en-GB"/>
           </a:p>
@@ -4537,7 +4537,7 @@
                               <a:solidFill>
                                 <a:schemeClr val="accent2"/>
                               </a:solidFill>
-                              <a:latin typeface="Cambria Math" panose="02040503050406030204" pitchFamily="18" charset="0"/>
+                              <a:latin typeface="Cambria Math"/>
                             </a:rPr>
                           </m:ctrlPr>
                         </m:sSubPr>
@@ -4578,7 +4578,7 @@
                                   <a:solidFill>
                                     <a:schemeClr val="accent2"/>
                                   </a:solidFill>
-                                  <a:latin typeface="Cambria Math" panose="02040503050406030204" pitchFamily="18" charset="0"/>
+                                  <a:latin typeface="Cambria Math"/>
                                 </a:rPr>
                               </m:ctrlPr>
                             </m:fPr>
@@ -4696,7 +4696,7 @@
                               <a:solidFill>
                                 <a:schemeClr val="accent2"/>
                               </a:solidFill>
-                              <a:latin typeface="Cambria Math" panose="02040503050406030204" pitchFamily="18" charset="0"/>
+                              <a:latin typeface="Cambria Math"/>
                             </a:rPr>
                           </m:ctrlPr>
                         </m:sSubPr>
@@ -4737,7 +4737,7 @@
                                   <a:solidFill>
                                     <a:schemeClr val="accent2"/>
                                   </a:solidFill>
-                                  <a:latin typeface="Cambria Math" panose="02040503050406030204" pitchFamily="18" charset="0"/>
+                                  <a:latin typeface="Cambria Math"/>
                                 </a:rPr>
                               </m:ctrlPr>
                             </m:fPr>
@@ -5883,7 +5883,7 @@
                               <a:solidFill>
                                 <a:schemeClr val="accent2"/>
                               </a:solidFill>
-                              <a:latin typeface="Cambria Math" panose="02040503050406030204" pitchFamily="18" charset="0"/>
+                              <a:latin typeface="Cambria Math"/>
                             </a:rPr>
                           </m:ctrlPr>
                         </m:sSubPr>
@@ -5924,7 +5924,7 @@
                                   <a:solidFill>
                                     <a:schemeClr val="accent2"/>
                                   </a:solidFill>
-                                  <a:latin typeface="Cambria Math" panose="02040503050406030204" pitchFamily="18" charset="0"/>
+                                  <a:latin typeface="Cambria Math"/>
                                 </a:rPr>
                               </m:ctrlPr>
                             </m:fPr>
@@ -6042,7 +6042,7 @@
                               <a:solidFill>
                                 <a:schemeClr val="accent2"/>
                               </a:solidFill>
-                              <a:latin typeface="Cambria Math" panose="02040503050406030204" pitchFamily="18" charset="0"/>
+                              <a:latin typeface="Cambria Math"/>
                             </a:rPr>
                           </m:ctrlPr>
                         </m:sSubPr>
@@ -6083,7 +6083,7 @@
                                   <a:solidFill>
                                     <a:schemeClr val="accent2"/>
                                   </a:solidFill>
-                                  <a:latin typeface="Cambria Math" panose="02040503050406030204" pitchFamily="18" charset="0"/>
+                                  <a:latin typeface="Cambria Math"/>
                                 </a:rPr>
                               </m:ctrlPr>
                             </m:fPr>
@@ -8746,7 +8746,7 @@
         <p:spPr>
           <a:xfrm>
             <a:off x="7294880" y="3926254"/>
-            <a:ext cx="1389985" cy="1754326"/>
+            <a:ext cx="1389985" cy="1908215"/>
           </a:xfrm>
           <a:prstGeom prst="rect">
             <a:avLst/>
@@ -8795,9 +8795,10 @@
               <a:t>Convective surface: </a:t>
             </a:r>
             <a:r>
-              <a:rPr lang="fr-FR" sz="1000" b="1" i="1" dirty="0" smtClean="0"/>
-              <a:t>A1</a:t>
-            </a:r>
+              <a:rPr lang="fr-FR" sz="1000" b="1" i="1" dirty="0" err="1" smtClean="0"/>
+              <a:t>A_conv_emitter</a:t>
+            </a:r>
+            <a:endParaRPr lang="fr-FR" sz="1000" b="1" i="1" dirty="0" smtClean="0"/>
           </a:p>
           <a:p>
             <a:pPr marL="171450" indent="-171450">
@@ -8809,9 +8810,10 @@
               <a:t>Equivalente radiant surface: </a:t>
             </a:r>
             <a:r>
-              <a:rPr lang="fr-FR" sz="1000" b="1" i="1" dirty="0"/>
-              <a:t>A2</a:t>
-            </a:r>
+              <a:rPr lang="fr-FR" sz="1000" b="1" i="1" dirty="0" err="1" smtClean="0"/>
+              <a:t>A_rad_emitter</a:t>
+            </a:r>
+            <a:endParaRPr lang="fr-FR" sz="1000" b="1" i="1" dirty="0"/>
           </a:p>
           <a:p>
             <a:pPr marL="171450" indent="-171450">
@@ -8878,8 +8880,8 @@
         </p:nvCxnSpPr>
         <p:spPr>
           <a:xfrm flipH="1" flipV="1">
-            <a:off x="6758600" y="3681919"/>
-            <a:ext cx="369756" cy="1428561"/>
+            <a:off x="6758600" y="3758863"/>
+            <a:ext cx="369756" cy="1351617"/>
           </a:xfrm>
           <a:prstGeom prst="straightConnector1">
             <a:avLst/>
@@ -8916,7 +8918,7 @@
         <p:spPr>
           <a:xfrm>
             <a:off x="5483519" y="3481864"/>
-            <a:ext cx="1275081" cy="400110"/>
+            <a:ext cx="1275081" cy="553998"/>
           </a:xfrm>
           <a:prstGeom prst="rect">
             <a:avLst/>
@@ -8942,8 +8944,8 @@
               <a:t> surface: </a:t>
             </a:r>
             <a:r>
-              <a:rPr lang="fr-FR" sz="1000" b="1" i="1" dirty="0" smtClean="0"/>
-              <a:t>A3</a:t>
+              <a:rPr lang="fr-FR" sz="1000" b="1" i="1" dirty="0" err="1" smtClean="0"/>
+              <a:t>A_in_casing</a:t>
             </a:r>
             <a:endParaRPr lang="en-GB" sz="1000" b="1" i="1" dirty="0"/>
           </a:p>
@@ -8958,7 +8960,7 @@
         <p:spPr>
           <a:xfrm>
             <a:off x="5466079" y="4142135"/>
-            <a:ext cx="1275081" cy="400110"/>
+            <a:ext cx="1275081" cy="553998"/>
           </a:xfrm>
           <a:prstGeom prst="rect">
             <a:avLst/>
@@ -8984,8 +8986,8 @@
               <a:t> surface : </a:t>
             </a:r>
             <a:r>
-              <a:rPr lang="fr-FR" sz="1000" b="1" i="1" dirty="0"/>
-              <a:t>A4</a:t>
+              <a:rPr lang="fr-FR" sz="1000" b="1" i="1" dirty="0" err="1" smtClean="0"/>
+              <a:t>A_conv_casing</a:t>
             </a:r>
             <a:endParaRPr lang="en-GB" sz="1000" b="1" i="1" dirty="0"/>
           </a:p>
@@ -9000,7 +9002,7 @@
         <p:spPr>
           <a:xfrm>
             <a:off x="5466079" y="4751735"/>
-            <a:ext cx="1275081" cy="400110"/>
+            <a:ext cx="1275081" cy="553998"/>
           </a:xfrm>
           <a:prstGeom prst="rect">
             <a:avLst/>
@@ -9026,8 +9028,8 @@
               <a:t> surface : </a:t>
             </a:r>
             <a:r>
-              <a:rPr lang="fr-FR" sz="1000" b="1" i="1" dirty="0" smtClean="0"/>
-              <a:t>A5</a:t>
+              <a:rPr lang="fr-FR" sz="1000" b="1" i="1" dirty="0" err="1" smtClean="0"/>
+              <a:t>A_rad_casing</a:t>
             </a:r>
             <a:endParaRPr lang="en-GB" sz="1000" b="1" i="1" dirty="0"/>
           </a:p>
@@ -9044,8 +9046,8 @@
         </p:nvCxnSpPr>
         <p:spPr>
           <a:xfrm>
-            <a:off x="6741160" y="4342190"/>
-            <a:ext cx="208280" cy="769248"/>
+            <a:off x="6741160" y="4419134"/>
+            <a:ext cx="208280" cy="692304"/>
           </a:xfrm>
           <a:prstGeom prst="straightConnector1">
             <a:avLst/>
@@ -9080,8 +9082,8 @@
         </p:nvCxnSpPr>
         <p:spPr>
           <a:xfrm>
-            <a:off x="6741160" y="4951790"/>
-            <a:ext cx="208280" cy="159648"/>
+            <a:off x="6741160" y="5028734"/>
+            <a:ext cx="208280" cy="82704"/>
           </a:xfrm>
           <a:prstGeom prst="straightConnector1">
             <a:avLst/>
@@ -9144,7 +9146,7 @@
         </p:nvCxnSpPr>
         <p:spPr>
           <a:xfrm flipV="1">
-            <a:off x="7231985" y="3926254"/>
+            <a:off x="7300565" y="3926254"/>
             <a:ext cx="0" cy="2372946"/>
           </a:xfrm>
           <a:prstGeom prst="straightConnector1">
@@ -9183,8 +9185,8 @@
         </p:nvCxnSpPr>
         <p:spPr>
           <a:xfrm flipH="1" flipV="1">
-            <a:off x="6741160" y="5581710"/>
-            <a:ext cx="490826" cy="717490"/>
+            <a:off x="6741160" y="5658654"/>
+            <a:ext cx="553720" cy="640546"/>
           </a:xfrm>
           <a:prstGeom prst="line">
             <a:avLst/>
@@ -9219,7 +9221,7 @@
         <p:spPr>
           <a:xfrm>
             <a:off x="5466079" y="5381655"/>
-            <a:ext cx="1275081" cy="400110"/>
+            <a:ext cx="1275081" cy="553998"/>
           </a:xfrm>
           <a:prstGeom prst="rect">
             <a:avLst/>
@@ -9258,7 +9260,7 @@
             </a:r>
             <a:r>
               <a:rPr lang="fr-FR" sz="1000" b="1" i="1" dirty="0" err="1" smtClean="0"/>
-              <a:t>L_emitter</a:t>
+              <a:t>Lc_emitter</a:t>
             </a:r>
             <a:endParaRPr lang="en-GB" sz="1000" b="1" i="1" dirty="0"/>
           </a:p>
@@ -9378,7 +9380,7 @@
             </a:r>
             <a:r>
               <a:rPr lang="fr-FR" sz="1000" b="1" i="1" dirty="0" err="1" smtClean="0"/>
-              <a:t>L_casing</a:t>
+              <a:t>Lc_casing</a:t>
             </a:r>
             <a:endParaRPr lang="en-GB" sz="1000" b="1" i="1" dirty="0"/>
           </a:p>
@@ -10585,11 +10587,7 @@
             </a:pPr>
             <a:r>
               <a:rPr lang="fr-FR" sz="1000" dirty="0" smtClean="0"/>
-              <a:t>Convective </a:t>
-            </a:r>
-            <a:r>
-              <a:rPr lang="fr-FR" sz="1000" dirty="0" smtClean="0"/>
-              <a:t>surface </a:t>
+              <a:t>Convective surface </a:t>
             </a:r>
             <a:endParaRPr lang="fr-FR" sz="1000" b="1" i="1" dirty="0" smtClean="0"/>
           </a:p>
@@ -10600,11 +10598,7 @@
             </a:pPr>
             <a:r>
               <a:rPr lang="fr-FR" sz="1000" dirty="0" smtClean="0"/>
-              <a:t>Equivalente radiant </a:t>
-            </a:r>
-            <a:r>
-              <a:rPr lang="fr-FR" sz="1000" dirty="0" smtClean="0"/>
-              <a:t>surface</a:t>
+              <a:t>Equivalente radiant surface</a:t>
             </a:r>
             <a:endParaRPr lang="fr-FR" sz="1000" b="1" i="1" dirty="0"/>
           </a:p>
@@ -10630,13 +10624,8 @@
             </a:pPr>
             <a:r>
               <a:rPr lang="fr-FR" sz="1000" dirty="0" smtClean="0"/>
-              <a:t>Mass</a:t>
-            </a:r>
-            <a:r>
-              <a:rPr lang="fr-FR" sz="1000" dirty="0" smtClean="0"/>
-              <a:t>:</a:t>
-            </a:r>
-            <a:endParaRPr lang="fr-FR" sz="1000" dirty="0" smtClean="0"/>
+              <a:t>Mass:</a:t>
+            </a:r>
           </a:p>
           <a:p>
             <a:pPr marL="171450" indent="-171450">
@@ -10761,7 +10750,7 @@
     </a:clrScheme>
     <a:fontScheme name="Office">
       <a:majorFont>
-        <a:latin typeface="Calibri Light" panose="020F0302020204030204"/>
+        <a:latin typeface="Calibri Light"/>
         <a:ea typeface=""/>
         <a:cs typeface=""/>
         <a:font script="Jpan" typeface="ＭＳ Ｐゴシック"/>
@@ -10796,7 +10785,7 @@
         <a:font script="Geor" typeface="Sylfaen"/>
       </a:majorFont>
       <a:minorFont>
-        <a:latin typeface="Calibri" panose="020F0502020204030204"/>
+        <a:latin typeface="Calibri"/>
         <a:ea typeface=""/>
         <a:cs typeface=""/>
         <a:font script="Jpan" typeface="ＭＳ Ｐゴシック"/>
@@ -10973,7 +10962,7 @@
   <a:extraClrSchemeLst/>
   <a:extLst>
     <a:ext uri="{05A4C25C-085E-4340-85A3-A5531E510DB2}">
-      <thm15:themeFamily xmlns:thm15="http://schemas.microsoft.com/office/thememl/2012/main" name="Office Theme" id="{62F939B6-93AF-4DB8-9C6B-D6C7DFDC589F}" vid="{4A3C46E8-61CC-4603-A589-7422A47A8E4A}"/>
+      <thm15:themeFamily xmlns:thm15="http://schemas.microsoft.com/office/thememl/2012/main" xmlns="" name="Office Theme" id="{62F939B6-93AF-4DB8-9C6B-D6C7DFDC589F}" vid="{4A3C46E8-61CC-4603-A589-7422A47A8E4A}"/>
     </a:ext>
   </a:extLst>
 </a:theme>

</xml_diff>

<commit_message>
-> Change the scheme from vertex centered to cell centered -> Addition of ghost node to avoid boundary PDEs in the inherited modules -> Update the HTML description and the images contained within
</commit_message>
<xml_diff>
--- a/Information/Graphs.pptx
+++ b/Information/Graphs.pptx
@@ -110,7 +110,18 @@
   </p:defaultTextStyle>
   <p:extLst>
     <p:ext uri="{EFAFB233-063F-42B5-8137-9DF3F51BA10A}">
-      <p15:sldGuideLst xmlns:p15="http://schemas.microsoft.com/office/powerpoint/2012/main" xmlns=""/>
+      <p15:sldGuideLst xmlns:p15="http://schemas.microsoft.com/office/powerpoint/2012/main">
+        <p15:guide id="1" orient="horz" pos="2160">
+          <p15:clr>
+            <a:srgbClr val="A4A3A4"/>
+          </p15:clr>
+        </p15:guide>
+        <p15:guide id="2" pos="3840">
+          <p15:clr>
+            <a:srgbClr val="A4A3A4"/>
+          </p15:clr>
+        </p15:guide>
+      </p15:sldGuideLst>
     </p:ext>
   </p:extLst>
 </p:presentation>
@@ -247,7 +258,7 @@
           <a:p>
             <a:fld id="{9C2A1DF7-758F-4EF0-A019-330F45C81B70}" type="datetimeFigureOut">
               <a:rPr lang="en-GB" smtClean="0"/>
-              <a:t>10/04/2020</a:t>
+              <a:t>07/12/2020</a:t>
             </a:fld>
             <a:endParaRPr lang="en-GB"/>
           </a:p>
@@ -417,7 +428,7 @@
           <a:p>
             <a:fld id="{9C2A1DF7-758F-4EF0-A019-330F45C81B70}" type="datetimeFigureOut">
               <a:rPr lang="en-GB" smtClean="0"/>
-              <a:t>10/04/2020</a:t>
+              <a:t>07/12/2020</a:t>
             </a:fld>
             <a:endParaRPr lang="en-GB"/>
           </a:p>
@@ -597,7 +608,7 @@
           <a:p>
             <a:fld id="{9C2A1DF7-758F-4EF0-A019-330F45C81B70}" type="datetimeFigureOut">
               <a:rPr lang="en-GB" smtClean="0"/>
-              <a:t>10/04/2020</a:t>
+              <a:t>07/12/2020</a:t>
             </a:fld>
             <a:endParaRPr lang="en-GB"/>
           </a:p>
@@ -767,7 +778,7 @@
           <a:p>
             <a:fld id="{9C2A1DF7-758F-4EF0-A019-330F45C81B70}" type="datetimeFigureOut">
               <a:rPr lang="en-GB" smtClean="0"/>
-              <a:t>10/04/2020</a:t>
+              <a:t>07/12/2020</a:t>
             </a:fld>
             <a:endParaRPr lang="en-GB"/>
           </a:p>
@@ -1013,7 +1024,7 @@
           <a:p>
             <a:fld id="{9C2A1DF7-758F-4EF0-A019-330F45C81B70}" type="datetimeFigureOut">
               <a:rPr lang="en-GB" smtClean="0"/>
-              <a:t>10/04/2020</a:t>
+              <a:t>07/12/2020</a:t>
             </a:fld>
             <a:endParaRPr lang="en-GB"/>
           </a:p>
@@ -1245,7 +1256,7 @@
           <a:p>
             <a:fld id="{9C2A1DF7-758F-4EF0-A019-330F45C81B70}" type="datetimeFigureOut">
               <a:rPr lang="en-GB" smtClean="0"/>
-              <a:t>10/04/2020</a:t>
+              <a:t>07/12/2020</a:t>
             </a:fld>
             <a:endParaRPr lang="en-GB"/>
           </a:p>
@@ -1612,7 +1623,7 @@
           <a:p>
             <a:fld id="{9C2A1DF7-758F-4EF0-A019-330F45C81B70}" type="datetimeFigureOut">
               <a:rPr lang="en-GB" smtClean="0"/>
-              <a:t>10/04/2020</a:t>
+              <a:t>07/12/2020</a:t>
             </a:fld>
             <a:endParaRPr lang="en-GB"/>
           </a:p>
@@ -1730,7 +1741,7 @@
           <a:p>
             <a:fld id="{9C2A1DF7-758F-4EF0-A019-330F45C81B70}" type="datetimeFigureOut">
               <a:rPr lang="en-GB" smtClean="0"/>
-              <a:t>10/04/2020</a:t>
+              <a:t>07/12/2020</a:t>
             </a:fld>
             <a:endParaRPr lang="en-GB"/>
           </a:p>
@@ -1825,7 +1836,7 @@
           <a:p>
             <a:fld id="{9C2A1DF7-758F-4EF0-A019-330F45C81B70}" type="datetimeFigureOut">
               <a:rPr lang="en-GB" smtClean="0"/>
-              <a:t>10/04/2020</a:t>
+              <a:t>07/12/2020</a:t>
             </a:fld>
             <a:endParaRPr lang="en-GB"/>
           </a:p>
@@ -2102,7 +2113,7 @@
           <a:p>
             <a:fld id="{9C2A1DF7-758F-4EF0-A019-330F45C81B70}" type="datetimeFigureOut">
               <a:rPr lang="en-GB" smtClean="0"/>
-              <a:t>10/04/2020</a:t>
+              <a:t>07/12/2020</a:t>
             </a:fld>
             <a:endParaRPr lang="en-GB"/>
           </a:p>
@@ -2355,7 +2366,7 @@
           <a:p>
             <a:fld id="{9C2A1DF7-758F-4EF0-A019-330F45C81B70}" type="datetimeFigureOut">
               <a:rPr lang="en-GB" smtClean="0"/>
-              <a:t>10/04/2020</a:t>
+              <a:t>07/12/2020</a:t>
             </a:fld>
             <a:endParaRPr lang="en-GB"/>
           </a:p>
@@ -2568,7 +2579,7 @@
           <a:p>
             <a:fld id="{9C2A1DF7-758F-4EF0-A019-330F45C81B70}" type="datetimeFigureOut">
               <a:rPr lang="en-GB" smtClean="0"/>
-              <a:t>10/04/2020</a:t>
+              <a:t>07/12/2020</a:t>
             </a:fld>
             <a:endParaRPr lang="en-GB"/>
           </a:p>
@@ -3293,7 +3304,7 @@
         </p:nvSpPr>
         <p:spPr>
           <a:xfrm>
-            <a:off x="2742472" y="2893874"/>
+            <a:off x="3054892" y="2893874"/>
             <a:ext cx="118716" cy="132734"/>
           </a:xfrm>
           <a:prstGeom prst="ellipse">
@@ -3339,7 +3350,7 @@
         </p:nvSpPr>
         <p:spPr>
           <a:xfrm>
-            <a:off x="3362400" y="2882313"/>
+            <a:off x="3677360" y="2882313"/>
             <a:ext cx="118716" cy="132734"/>
           </a:xfrm>
           <a:prstGeom prst="ellipse">
@@ -3385,7 +3396,7 @@
         </p:nvSpPr>
         <p:spPr>
           <a:xfrm>
-            <a:off x="3982328" y="2882313"/>
+            <a:off x="4307448" y="2882313"/>
             <a:ext cx="118716" cy="132734"/>
           </a:xfrm>
           <a:prstGeom prst="ellipse">
@@ -3425,20 +3436,20 @@
       </p:sp>
       <p:sp>
         <p:nvSpPr>
-          <p:cNvPr id="26" name="Ellipse 25"/>
+          <p:cNvPr id="27" name="Ellipse 26"/>
           <p:cNvSpPr/>
           <p:nvPr/>
         </p:nvSpPr>
         <p:spPr>
           <a:xfrm>
-            <a:off x="4609630" y="2882313"/>
+            <a:off x="4914352" y="2882313"/>
             <a:ext cx="118716" cy="132734"/>
           </a:xfrm>
           <a:prstGeom prst="ellipse">
             <a:avLst/>
           </a:prstGeom>
           <a:solidFill>
-            <a:schemeClr val="accent6"/>
+            <a:srgbClr val="FF0000"/>
           </a:solidFill>
           <a:ln>
             <a:noFill/>
@@ -3471,59 +3482,13 @@
       </p:sp>
       <p:sp>
         <p:nvSpPr>
-          <p:cNvPr id="27" name="Ellipse 26"/>
-          <p:cNvSpPr/>
-          <p:nvPr/>
-        </p:nvSpPr>
-        <p:spPr>
-          <a:xfrm>
-            <a:off x="5236932" y="2882313"/>
-            <a:ext cx="118716" cy="132734"/>
-          </a:xfrm>
-          <a:prstGeom prst="ellipse">
-            <a:avLst/>
-          </a:prstGeom>
-          <a:solidFill>
-            <a:srgbClr val="FF0000"/>
-          </a:solidFill>
-          <a:ln>
-            <a:noFill/>
-          </a:ln>
-        </p:spPr>
-        <p:style>
-          <a:lnRef idx="2">
-            <a:schemeClr val="accent1">
-              <a:shade val="50000"/>
-            </a:schemeClr>
-          </a:lnRef>
-          <a:fillRef idx="1">
-            <a:schemeClr val="accent1"/>
-          </a:fillRef>
-          <a:effectRef idx="0">
-            <a:schemeClr val="accent1"/>
-          </a:effectRef>
-          <a:fontRef idx="minor">
-            <a:schemeClr val="lt1"/>
-          </a:fontRef>
-        </p:style>
-        <p:txBody>
-          <a:bodyPr rtlCol="0" anchor="ctr"/>
-          <a:lstStyle/>
-          <a:p>
-            <a:pPr algn="ctr"/>
-            <a:endParaRPr lang="en-GB" dirty="0"/>
-          </a:p>
-        </p:txBody>
-      </p:sp>
-      <p:sp>
-        <p:nvSpPr>
           <p:cNvPr id="28" name="Ellipse 27"/>
           <p:cNvSpPr/>
           <p:nvPr/>
         </p:nvSpPr>
         <p:spPr>
           <a:xfrm>
-            <a:off x="2108041" y="2888690"/>
+            <a:off x="2417921" y="2888690"/>
             <a:ext cx="118716" cy="132734"/>
           </a:xfrm>
           <a:prstGeom prst="ellipse">
@@ -3998,10 +3963,10 @@
         </p:nvGrpSpPr>
         <p:grpSpPr>
           <a:xfrm>
-            <a:off x="2052121" y="3046914"/>
-            <a:ext cx="3504332" cy="276711"/>
-            <a:chOff x="2047201" y="2562677"/>
-            <a:chExt cx="3504332" cy="276711"/>
+            <a:off x="2334061" y="3046914"/>
+            <a:ext cx="2922672" cy="276711"/>
+            <a:chOff x="2329141" y="2562677"/>
+            <a:chExt cx="2922672" cy="276711"/>
           </a:xfrm>
         </p:grpSpPr>
         <p:sp>
@@ -4012,7 +3977,7 @@
           </p:nvSpPr>
           <p:spPr>
             <a:xfrm>
-              <a:off x="2047201" y="2568551"/>
+              <a:off x="2329141" y="2568551"/>
               <a:ext cx="315364" cy="261610"/>
             </a:xfrm>
             <a:prstGeom prst="rect">
@@ -4058,7 +4023,7 @@
           </p:nvSpPr>
           <p:spPr>
             <a:xfrm>
-              <a:off x="2656051" y="2566593"/>
+              <a:off x="2960851" y="2566593"/>
               <a:ext cx="315364" cy="261610"/>
             </a:xfrm>
             <a:prstGeom prst="rect">
@@ -4098,59 +4063,13 @@
         </p:sp>
         <p:sp>
           <p:nvSpPr>
-            <p:cNvPr id="42" name="ZoneTexte 41"/>
-            <p:cNvSpPr txBox="1"/>
-            <p:nvPr/>
-          </p:nvSpPr>
-          <p:spPr>
-            <a:xfrm>
-              <a:off x="4503765" y="2564635"/>
-              <a:ext cx="345878" cy="261610"/>
-            </a:xfrm>
-            <a:prstGeom prst="rect">
-              <a:avLst/>
-            </a:prstGeom>
-            <a:noFill/>
-          </p:spPr>
-          <p:txBody>
-            <a:bodyPr wrap="square" rtlCol="0">
-              <a:spAutoFit/>
-            </a:bodyPr>
-            <a:lstStyle/>
-            <a:p>
-              <a:r>
-                <a:rPr lang="fr-FR" sz="1100" noProof="1" smtClean="0">
-                  <a:solidFill>
-                    <a:schemeClr val="accent6"/>
-                  </a:solidFill>
-                </a:rPr>
-                <a:t>u</a:t>
-              </a:r>
-              <a:r>
-                <a:rPr lang="fr-FR" sz="1100" baseline="-25000" noProof="1" smtClean="0">
-                  <a:solidFill>
-                    <a:schemeClr val="accent6"/>
-                  </a:solidFill>
-                </a:rPr>
-                <a:t>N</a:t>
-              </a:r>
-              <a:endParaRPr lang="fr-FR" sz="1100" baseline="-25000" noProof="1">
-                <a:solidFill>
-                  <a:schemeClr val="accent6"/>
-                </a:solidFill>
-              </a:endParaRPr>
-            </a:p>
-          </p:txBody>
-        </p:sp>
-        <p:sp>
-          <p:nvSpPr>
             <p:cNvPr id="43" name="ZoneTexte 42"/>
             <p:cNvSpPr txBox="1"/>
             <p:nvPr/>
           </p:nvSpPr>
           <p:spPr>
             <a:xfrm>
-              <a:off x="5112611" y="2562677"/>
+              <a:off x="4812891" y="2562677"/>
               <a:ext cx="438922" cy="261610"/>
             </a:xfrm>
             <a:prstGeom prst="rect">
@@ -4165,7 +4084,7 @@
             <a:lstStyle/>
             <a:p>
               <a:r>
-                <a:rPr lang="fr-FR" sz="1100" dirty="0">
+                <a:rPr lang="fr-FR" sz="1100" dirty="0" err="1" smtClean="0">
                   <a:solidFill>
                     <a:srgbClr val="FF0000"/>
                   </a:solidFill>
@@ -4173,12 +4092,12 @@
                 <a:t>u</a:t>
               </a:r>
               <a:r>
-                <a:rPr lang="fr-FR" sz="1100" baseline="-25000" dirty="0" smtClean="0">
+                <a:rPr lang="fr-FR" sz="1100" baseline="-25000" dirty="0" err="1" smtClean="0">
                   <a:solidFill>
                     <a:srgbClr val="FF0000"/>
                   </a:solidFill>
                 </a:rPr>
-                <a:t>N+1</a:t>
+                <a:t>N</a:t>
               </a:r>
               <a:endParaRPr lang="en-GB" sz="1100" baseline="-25000" dirty="0">
                 <a:solidFill>
@@ -4196,7 +4115,7 @@
           </p:nvSpPr>
           <p:spPr>
             <a:xfrm>
-              <a:off x="3288649" y="2577778"/>
+              <a:off x="3601069" y="2577778"/>
               <a:ext cx="315364" cy="261610"/>
             </a:xfrm>
             <a:prstGeom prst="rect">
@@ -4386,7 +4305,7 @@
         </p:nvSpPr>
         <p:spPr>
           <a:xfrm>
-            <a:off x="3141227" y="2886730"/>
+            <a:off x="3451107" y="2886730"/>
             <a:ext cx="579007" cy="132734"/>
           </a:xfrm>
           <a:prstGeom prst="rect">
@@ -4433,7 +4352,7 @@
         </p:nvCxnSpPr>
         <p:spPr>
           <a:xfrm flipH="1" flipV="1">
-            <a:off x="3324189" y="3088553"/>
+            <a:off x="3616289" y="3088553"/>
             <a:ext cx="156" cy="397597"/>
           </a:xfrm>
           <a:prstGeom prst="straightConnector1">
@@ -4469,7 +4388,7 @@
         </p:nvSpPr>
         <p:spPr>
           <a:xfrm>
-            <a:off x="2910767" y="3440935"/>
+            <a:off x="3078407" y="3440935"/>
             <a:ext cx="656305" cy="430887"/>
           </a:xfrm>
           <a:prstGeom prst="rect">
@@ -4499,8 +4418,8 @@
           </a:p>
         </p:txBody>
       </p:sp>
-      <mc:AlternateContent xmlns:mc="http://schemas.openxmlformats.org/markup-compatibility/2006" xmlns:a14="http://schemas.microsoft.com/office/drawing/2010/main">
-        <mc:Choice Requires="a14">
+      <mc:AlternateContent xmlns:mc="http://schemas.openxmlformats.org/markup-compatibility/2006">
+        <mc:Choice xmlns:a14="http://schemas.microsoft.com/office/drawing/2010/main" Requires="a14">
           <p:sp>
             <p:nvSpPr>
               <p:cNvPr id="2" name="ZoneTexte 1"/>
@@ -4509,7 +4428,7 @@
             </p:nvSpPr>
             <p:spPr>
               <a:xfrm>
-                <a:off x="3068970" y="3062790"/>
+                <a:off x="3325510" y="3062790"/>
                 <a:ext cx="201529" cy="164404"/>
               </a:xfrm>
               <a:prstGeom prst="rect">
@@ -4537,7 +4456,7 @@
                               <a:solidFill>
                                 <a:schemeClr val="accent2"/>
                               </a:solidFill>
-                              <a:latin typeface="Cambria Math"/>
+                              <a:latin typeface="Cambria Math" panose="02040503050406030204" pitchFamily="18" charset="0"/>
                             </a:rPr>
                           </m:ctrlPr>
                         </m:sSubPr>
@@ -4578,7 +4497,7 @@
                                   <a:solidFill>
                                     <a:schemeClr val="accent2"/>
                                   </a:solidFill>
-                                  <a:latin typeface="Cambria Math"/>
+                                  <a:latin typeface="Cambria Math" panose="02040503050406030204" pitchFamily="18" charset="0"/>
                                 </a:rPr>
                               </m:ctrlPr>
                             </m:fPr>
@@ -4619,7 +4538,7 @@
             </p:txBody>
           </p:sp>
         </mc:Choice>
-        <mc:Fallback xmlns="">
+        <mc:Fallback>
           <p:sp>
             <p:nvSpPr>
               <p:cNvPr id="2" name="ZoneTexte 1"/>
@@ -4630,7 +4549,7 @@
             </p:nvSpPr>
             <p:spPr>
               <a:xfrm>
-                <a:off x="3068970" y="3062790"/>
+                <a:off x="3325510" y="3062790"/>
                 <a:ext cx="201529" cy="164404"/>
               </a:xfrm>
               <a:prstGeom prst="rect">
@@ -4648,7 +4567,7 @@
               <a:lstStyle/>
               <a:p>
                 <a:r>
-                  <a:rPr lang="en-GB">
+                  <a:rPr lang="fr-FR">
                     <a:noFill/>
                   </a:rPr>
                   <a:t> </a:t>
@@ -4658,8 +4577,8 @@
           </p:sp>
         </mc:Fallback>
       </mc:AlternateContent>
-      <mc:AlternateContent xmlns:mc="http://schemas.openxmlformats.org/markup-compatibility/2006" xmlns:a14="http://schemas.microsoft.com/office/drawing/2010/main">
-        <mc:Choice Requires="a14">
+      <mc:AlternateContent xmlns:mc="http://schemas.openxmlformats.org/markup-compatibility/2006">
+        <mc:Choice xmlns:a14="http://schemas.microsoft.com/office/drawing/2010/main" Requires="a14">
           <p:sp>
             <p:nvSpPr>
               <p:cNvPr id="50" name="ZoneTexte 49"/>
@@ -4668,7 +4587,7 @@
             </p:nvSpPr>
             <p:spPr>
               <a:xfrm>
-                <a:off x="3625561" y="3061047"/>
+                <a:off x="3950681" y="3061047"/>
                 <a:ext cx="187103" cy="164404"/>
               </a:xfrm>
               <a:prstGeom prst="rect">
@@ -4696,7 +4615,7 @@
                               <a:solidFill>
                                 <a:schemeClr val="accent2"/>
                               </a:solidFill>
-                              <a:latin typeface="Cambria Math"/>
+                              <a:latin typeface="Cambria Math" panose="02040503050406030204" pitchFamily="18" charset="0"/>
                             </a:rPr>
                           </m:ctrlPr>
                         </m:sSubPr>
@@ -4737,7 +4656,7 @@
                                   <a:solidFill>
                                     <a:schemeClr val="accent2"/>
                                   </a:solidFill>
-                                  <a:latin typeface="Cambria Math"/>
+                                  <a:latin typeface="Cambria Math" panose="02040503050406030204" pitchFamily="18" charset="0"/>
                                 </a:rPr>
                               </m:ctrlPr>
                             </m:fPr>
@@ -4778,7 +4697,7 @@
             </p:txBody>
           </p:sp>
         </mc:Choice>
-        <mc:Fallback xmlns="">
+        <mc:Fallback>
           <p:sp>
             <p:nvSpPr>
               <p:cNvPr id="50" name="ZoneTexte 49"/>
@@ -4789,7 +4708,7 @@
             </p:nvSpPr>
             <p:spPr>
               <a:xfrm>
-                <a:off x="3625561" y="3061047"/>
+                <a:off x="3950681" y="3061047"/>
                 <a:ext cx="187103" cy="164404"/>
               </a:xfrm>
               <a:prstGeom prst="rect">
@@ -4798,7 +4717,7 @@
               <a:blipFill rotWithShape="0">
                 <a:blip r:embed="rId3"/>
                 <a:stretch>
-                  <a:fillRect l="-6667" r="-10000" b="-14815"/>
+                  <a:fillRect l="-6452" r="-6452" b="-14815"/>
                 </a:stretch>
               </a:blipFill>
             </p:spPr>
@@ -4807,7 +4726,7 @@
               <a:lstStyle/>
               <a:p>
                 <a:r>
-                  <a:rPr lang="en-GB">
+                  <a:rPr lang="fr-FR">
                     <a:noFill/>
                   </a:rPr>
                   <a:t> </a:t>
@@ -5883,7 +5802,7 @@
                               <a:solidFill>
                                 <a:schemeClr val="accent2"/>
                               </a:solidFill>
-                              <a:latin typeface="Cambria Math"/>
+                              <a:latin typeface="Cambria Math" panose="02040503050406030204" pitchFamily="18" charset="0"/>
                             </a:rPr>
                           </m:ctrlPr>
                         </m:sSubPr>
@@ -5924,7 +5843,7 @@
                                   <a:solidFill>
                                     <a:schemeClr val="accent2"/>
                                   </a:solidFill>
-                                  <a:latin typeface="Cambria Math"/>
+                                  <a:latin typeface="Cambria Math" panose="02040503050406030204" pitchFamily="18" charset="0"/>
                                 </a:rPr>
                               </m:ctrlPr>
                             </m:fPr>
@@ -6042,7 +5961,7 @@
                               <a:solidFill>
                                 <a:schemeClr val="accent2"/>
                               </a:solidFill>
-                              <a:latin typeface="Cambria Math"/>
+                              <a:latin typeface="Cambria Math" panose="02040503050406030204" pitchFamily="18" charset="0"/>
                             </a:rPr>
                           </m:ctrlPr>
                         </m:sSubPr>
@@ -6083,7 +6002,7 @@
                                   <a:solidFill>
                                     <a:schemeClr val="accent2"/>
                                   </a:solidFill>
-                                  <a:latin typeface="Cambria Math"/>
+                                  <a:latin typeface="Cambria Math" panose="02040503050406030204" pitchFamily="18" charset="0"/>
                                 </a:rPr>
                               </m:ctrlPr>
                             </m:fPr>
@@ -10962,7 +10881,7 @@
   <a:extraClrSchemeLst/>
   <a:extLst>
     <a:ext uri="{05A4C25C-085E-4340-85A3-A5531E510DB2}">
-      <thm15:themeFamily xmlns:thm15="http://schemas.microsoft.com/office/thememl/2012/main" xmlns="" name="Office Theme" id="{62F939B6-93AF-4DB8-9C6B-D6C7DFDC589F}" vid="{4A3C46E8-61CC-4603-A589-7422A47A8E4A}"/>
+      <thm15:themeFamily xmlns:thm15="http://schemas.microsoft.com/office/thememl/2012/main" name="Office Theme" id="{62F939B6-93AF-4DB8-9C6B-D6C7DFDC589F}" vid="{4A3C46E8-61CC-4603-A589-7422A47A8E4A}"/>
     </a:ext>
   </a:extLst>
 </a:theme>

</xml_diff>